<commit_message>
added error pages that I use on geisersoft skinned for this app
</commit_message>
<xml_diff>
--- a/documentation/AI Presentation Coach.pptx
+++ b/documentation/AI Presentation Coach.pptx
@@ -1713,7 +1713,7 @@
           </a:prstGeom>
           <a:extLst>
             <a:ext uri="{C572A759-6A51-4108-AA02-DFA0A04FC94B}">
-              <ma14:wrappingTextBoxFlag xmlns="" xmlns:ma14="http://schemas.microsoft.com/office/mac/drawingml/2011/main" val="0"/>
+              <ma14:wrappingTextBoxFlag xmlns:ma14="http://schemas.microsoft.com/office/mac/drawingml/2011/main" xmlns="" val="0"/>
             </a:ext>
           </a:extLst>
         </p:spPr>
@@ -1866,7 +1866,7 @@
           </a:prstGeom>
           <a:extLst>
             <a:ext uri="{C572A759-6A51-4108-AA02-DFA0A04FC94B}">
-              <ma14:wrappingTextBoxFlag xmlns="" xmlns:ma14="http://schemas.microsoft.com/office/mac/drawingml/2011/main" val="0"/>
+              <ma14:wrappingTextBoxFlag xmlns:ma14="http://schemas.microsoft.com/office/mac/drawingml/2011/main" xmlns="" val="0"/>
             </a:ext>
           </a:extLst>
         </p:spPr>
@@ -4804,7 +4804,7 @@
         <p:spPr>
           <a:xfrm>
             <a:off x="8565005" y="2119074"/>
-            <a:ext cx="3255518" cy="3231654"/>
+            <a:ext cx="3255518" cy="4062651"/>
           </a:xfrm>
           <a:prstGeom prst="rect">
             <a:avLst/>
@@ -4882,7 +4882,7 @@
                   <a:schemeClr val="bg1"/>
                 </a:solidFill>
               </a:rPr>
-              <a:t>LLM usage is not included in these costs</a:t>
+              <a:t>LLM usage was not included in these costs. They usually show up each day but were delayed in June.</a:t>
             </a:r>
           </a:p>
           <a:p>
@@ -6058,7 +6058,7 @@
           </a:prstGeom>
           <a:extLst>
             <a:ext uri="{C572A759-6A51-4108-AA02-DFA0A04FC94B}">
-              <ma14:wrappingTextBoxFlag xmlns="" xmlns:ma14="http://schemas.microsoft.com/office/mac/drawingml/2011/main" val="0"/>
+              <ma14:wrappingTextBoxFlag xmlns:ma14="http://schemas.microsoft.com/office/mac/drawingml/2011/main" xmlns="" val="0"/>
             </a:ext>
           </a:extLst>
         </p:spPr>
@@ -26282,7 +26282,7 @@
         </p:nvSpPr>
         <p:spPr>
           <a:xfrm>
-            <a:off x="1408176" y="5084064"/>
+            <a:off x="1103375" y="5084064"/>
             <a:ext cx="2011680" cy="530352"/>
           </a:xfrm>
           <a:prstGeom prst="rect">
@@ -26320,7 +26320,7 @@
         </p:nvSpPr>
         <p:spPr>
           <a:xfrm>
-            <a:off x="1408176" y="5669280"/>
+            <a:off x="1103375" y="5669280"/>
             <a:ext cx="2011680" cy="384048"/>
           </a:xfrm>
           <a:prstGeom prst="rect">
@@ -26358,7 +26358,7 @@
         </p:nvSpPr>
         <p:spPr>
           <a:xfrm>
-            <a:off x="4224528" y="5084064"/>
+            <a:off x="3955585" y="5084064"/>
             <a:ext cx="1828800" cy="530352"/>
           </a:xfrm>
           <a:prstGeom prst="rect">
@@ -26396,7 +26396,7 @@
         </p:nvSpPr>
         <p:spPr>
           <a:xfrm>
-            <a:off x="4224528" y="5669280"/>
+            <a:off x="3955585" y="5669280"/>
             <a:ext cx="1828800" cy="384048"/>
           </a:xfrm>
           <a:prstGeom prst="rect">
@@ -26510,7 +26510,7 @@
         </p:nvSpPr>
         <p:spPr>
           <a:xfrm>
-            <a:off x="8997696" y="5084064"/>
+            <a:off x="9275602" y="5084064"/>
             <a:ext cx="2011680" cy="530352"/>
           </a:xfrm>
           <a:prstGeom prst="rect">
@@ -26531,12 +26531,16 @@
             <a:r>
               <a:rPr lang="en-US" sz="2600" b="1" dirty="0">
                 <a:solidFill>
-                  <a:srgbClr val="FF9B55"/>
+                  <a:srgbClr val="B68CFF"/>
                 </a:solidFill>
               </a:rPr>
               <a:t>~$0</a:t>
             </a:r>
-            <a:endParaRPr lang="en-US" sz="2600" dirty="0"/>
+            <a:endParaRPr lang="en-US" sz="2600" dirty="0">
+              <a:solidFill>
+                <a:srgbClr val="B68CFF"/>
+              </a:solidFill>
+            </a:endParaRPr>
           </a:p>
         </p:txBody>
       </p:sp>
@@ -26548,7 +26552,7 @@
         </p:nvSpPr>
         <p:spPr>
           <a:xfrm>
-            <a:off x="8997696" y="5669280"/>
+            <a:off x="9275602" y="5669280"/>
             <a:ext cx="2011680" cy="384048"/>
           </a:xfrm>
           <a:prstGeom prst="rect">
@@ -26636,7 +26640,7 @@
           </a:prstGeom>
           <a:extLst>
             <a:ext uri="{C572A759-6A51-4108-AA02-DFA0A04FC94B}">
-              <ma14:wrappingTextBoxFlag xmlns="" xmlns:ma14="http://schemas.microsoft.com/office/mac/drawingml/2011/main" val="0"/>
+              <ma14:wrappingTextBoxFlag xmlns:ma14="http://schemas.microsoft.com/office/mac/drawingml/2011/main" xmlns="" val="0"/>
             </a:ext>
           </a:extLst>
         </p:spPr>
@@ -27781,7 +27785,7 @@
           </a:prstGeom>
           <a:extLst>
             <a:ext uri="{C572A759-6A51-4108-AA02-DFA0A04FC94B}">
-              <ma14:wrappingTextBoxFlag xmlns="" xmlns:ma14="http://schemas.microsoft.com/office/mac/drawingml/2011/main" val="0"/>
+              <ma14:wrappingTextBoxFlag xmlns:ma14="http://schemas.microsoft.com/office/mac/drawingml/2011/main" xmlns="" val="0"/>
             </a:ext>
           </a:extLst>
         </p:spPr>
@@ -28964,7 +28968,7 @@
           </a:prstGeom>
           <a:extLst>
             <a:ext uri="{C572A759-6A51-4108-AA02-DFA0A04FC94B}">
-              <ma14:wrappingTextBoxFlag xmlns="" xmlns:ma14="http://schemas.microsoft.com/office/mac/drawingml/2011/main" val="0"/>
+              <ma14:wrappingTextBoxFlag xmlns:ma14="http://schemas.microsoft.com/office/mac/drawingml/2011/main" xmlns="" val="0"/>
             </a:ext>
           </a:extLst>
         </p:spPr>
@@ -29719,7 +29723,7 @@
           </a:prstGeom>
           <a:extLst>
             <a:ext uri="{C572A759-6A51-4108-AA02-DFA0A04FC94B}">
-              <ma14:wrappingTextBoxFlag xmlns="" xmlns:ma14="http://schemas.microsoft.com/office/mac/drawingml/2011/main" val="0"/>
+              <ma14:wrappingTextBoxFlag xmlns:ma14="http://schemas.microsoft.com/office/mac/drawingml/2011/main" xmlns="" val="0"/>
             </a:ext>
           </a:extLst>
         </p:spPr>
@@ -30727,7 +30731,7 @@
           </a:prstGeom>
           <a:extLst>
             <a:ext uri="{C572A759-6A51-4108-AA02-DFA0A04FC94B}">
-              <ma14:wrappingTextBoxFlag xmlns="" xmlns:ma14="http://schemas.microsoft.com/office/mac/drawingml/2011/main" val="0"/>
+              <ma14:wrappingTextBoxFlag xmlns:ma14="http://schemas.microsoft.com/office/mac/drawingml/2011/main" xmlns="" val="0"/>
             </a:ext>
           </a:extLst>
         </p:spPr>
@@ -30898,7 +30902,7 @@
                   <a:schemeClr val="accent2"/>
                 </a:solidFill>
               </a:rPr>
-              <a:t>Infrastructure only: LLM costs must be determined; cost and output will vary by LLM.</a:t>
+              <a:t>Infrastructure only: LLM costs must be determined; cost and output will vary based on LLMs used.</a:t>
             </a:r>
           </a:p>
         </p:txBody>
@@ -31072,7 +31076,7 @@
         </p:nvSpPr>
         <p:spPr>
           <a:xfrm>
-            <a:off x="2511910" y="2395728"/>
+            <a:off x="2924285" y="2395728"/>
             <a:ext cx="2743200" cy="310896"/>
           </a:xfrm>
           <a:prstGeom prst="rect">
@@ -31110,7 +31114,7 @@
         </p:nvSpPr>
         <p:spPr>
           <a:xfrm>
-            <a:off x="6460863" y="2395728"/>
+            <a:off x="6873238" y="2395728"/>
             <a:ext cx="3063240" cy="310896"/>
           </a:xfrm>
           <a:prstGeom prst="rect">
@@ -31148,7 +31152,7 @@
         </p:nvSpPr>
         <p:spPr>
           <a:xfrm>
-            <a:off x="822960" y="2834640"/>
+            <a:off x="1235335" y="2834640"/>
             <a:ext cx="1508760" cy="347472"/>
           </a:xfrm>
           <a:prstGeom prst="roundRect">
@@ -31196,7 +31200,7 @@
         </p:nvSpPr>
         <p:spPr>
           <a:xfrm>
-            <a:off x="2450592" y="2779776"/>
+            <a:off x="2862967" y="2779776"/>
             <a:ext cx="2743200" cy="457200"/>
           </a:xfrm>
           <a:prstGeom prst="roundRect">
@@ -31242,7 +31246,7 @@
         </p:nvSpPr>
         <p:spPr>
           <a:xfrm>
-            <a:off x="6428232" y="2779776"/>
+            <a:off x="6840607" y="2779776"/>
             <a:ext cx="3154680" cy="457200"/>
           </a:xfrm>
           <a:prstGeom prst="roundRect">
@@ -31288,7 +31292,7 @@
         </p:nvSpPr>
         <p:spPr>
           <a:xfrm>
-            <a:off x="822960" y="3493008"/>
+            <a:off x="1235335" y="3493008"/>
             <a:ext cx="1508760" cy="347472"/>
           </a:xfrm>
           <a:prstGeom prst="roundRect">
@@ -31336,7 +31340,7 @@
         </p:nvSpPr>
         <p:spPr>
           <a:xfrm>
-            <a:off x="2450592" y="3438144"/>
+            <a:off x="2862967" y="3438144"/>
             <a:ext cx="2743200" cy="457200"/>
           </a:xfrm>
           <a:prstGeom prst="roundRect">
@@ -31382,7 +31386,7 @@
         </p:nvSpPr>
         <p:spPr>
           <a:xfrm>
-            <a:off x="6428232" y="3438144"/>
+            <a:off x="6840607" y="3438144"/>
             <a:ext cx="3154680" cy="457200"/>
           </a:xfrm>
           <a:prstGeom prst="roundRect">
@@ -31428,7 +31432,7 @@
         </p:nvSpPr>
         <p:spPr>
           <a:xfrm>
-            <a:off x="822960" y="4151376"/>
+            <a:off x="1235335" y="4151376"/>
             <a:ext cx="1508760" cy="347472"/>
           </a:xfrm>
           <a:prstGeom prst="roundRect">
@@ -31476,7 +31480,7 @@
         </p:nvSpPr>
         <p:spPr>
           <a:xfrm>
-            <a:off x="2450592" y="4096512"/>
+            <a:off x="2862967" y="4096512"/>
             <a:ext cx="2743200" cy="457200"/>
           </a:xfrm>
           <a:prstGeom prst="roundRect">
@@ -31508,7 +31512,15 @@
                   <a:srgbClr val="F5F7FA"/>
                 </a:solidFill>
               </a:rPr>
-              <a:t>~50-100 ms per file</a:t>
+              <a:t>~50-100 </a:t>
+            </a:r>
+            <a:r>
+              <a:rPr lang="en-US" sz="1080" dirty="0" err="1">
+                <a:solidFill>
+                  <a:srgbClr val="F5F7FA"/>
+                </a:solidFill>
+              </a:rPr>
+              <a:t>ms</a:t>
             </a:r>
             <a:endParaRPr lang="en-US" sz="1080" dirty="0"/>
           </a:p>
@@ -31522,7 +31534,7 @@
         </p:nvSpPr>
         <p:spPr>
           <a:xfrm>
-            <a:off x="6428232" y="4096512"/>
+            <a:off x="6840607" y="4096512"/>
             <a:ext cx="3154680" cy="457200"/>
           </a:xfrm>
           <a:prstGeom prst="roundRect">
@@ -31568,7 +31580,7 @@
         </p:nvSpPr>
         <p:spPr>
           <a:xfrm>
-            <a:off x="822960" y="4809744"/>
+            <a:off x="1235335" y="4809744"/>
             <a:ext cx="1508760" cy="347472"/>
           </a:xfrm>
           <a:prstGeom prst="roundRect">
@@ -31616,7 +31628,7 @@
         </p:nvSpPr>
         <p:spPr>
           <a:xfrm>
-            <a:off x="2450592" y="4754880"/>
+            <a:off x="2862967" y="4754880"/>
             <a:ext cx="2743200" cy="457200"/>
           </a:xfrm>
           <a:prstGeom prst="roundRect">
@@ -31662,7 +31674,7 @@
         </p:nvSpPr>
         <p:spPr>
           <a:xfrm>
-            <a:off x="6428232" y="4754880"/>
+            <a:off x="6840607" y="4754880"/>
             <a:ext cx="3154680" cy="457200"/>
           </a:xfrm>
           <a:prstGeom prst="roundRect">
@@ -31804,7 +31816,7 @@
           </a:prstGeom>
           <a:extLst>
             <a:ext uri="{C572A759-6A51-4108-AA02-DFA0A04FC94B}">
-              <ma14:wrappingTextBoxFlag xmlns="" xmlns:ma14="http://schemas.microsoft.com/office/mac/drawingml/2011/main" val="0"/>
+              <ma14:wrappingTextBoxFlag xmlns:ma14="http://schemas.microsoft.com/office/mac/drawingml/2011/main" xmlns="" val="0"/>
             </a:ext>
           </a:extLst>
         </p:spPr>
@@ -32461,7 +32473,7 @@
           </a:prstGeom>
           <a:extLst>
             <a:ext uri="{C572A759-6A51-4108-AA02-DFA0A04FC94B}">
-              <ma14:wrappingTextBoxFlag xmlns="" xmlns:ma14="http://schemas.microsoft.com/office/mac/drawingml/2011/main" val="0"/>
+              <ma14:wrappingTextBoxFlag xmlns:ma14="http://schemas.microsoft.com/office/mac/drawingml/2011/main" xmlns="" val="0"/>
             </a:ext>
           </a:extLst>
         </p:spPr>
@@ -33342,7 +33354,7 @@
           </a:prstGeom>
           <a:extLst>
             <a:ext uri="{C572A759-6A51-4108-AA02-DFA0A04FC94B}">
-              <ma14:wrappingTextBoxFlag xmlns="" xmlns:ma14="http://schemas.microsoft.com/office/mac/drawingml/2011/main" val="0"/>
+              <ma14:wrappingTextBoxFlag xmlns:ma14="http://schemas.microsoft.com/office/mac/drawingml/2011/main" xmlns="" val="0"/>
             </a:ext>
           </a:extLst>
         </p:spPr>
@@ -34052,7 +34064,7 @@
           </a:prstGeom>
           <a:extLst>
             <a:ext uri="{C572A759-6A51-4108-AA02-DFA0A04FC94B}">
-              <ma14:wrappingTextBoxFlag xmlns="" xmlns:ma14="http://schemas.microsoft.com/office/mac/drawingml/2011/main" val="0"/>
+              <ma14:wrappingTextBoxFlag xmlns:ma14="http://schemas.microsoft.com/office/mac/drawingml/2011/main" xmlns="" val="0"/>
             </a:ext>
           </a:extLst>
         </p:spPr>
@@ -34839,7 +34851,7 @@
           </a:prstGeom>
           <a:extLst>
             <a:ext uri="{C572A759-6A51-4108-AA02-DFA0A04FC94B}">
-              <ma14:wrappingTextBoxFlag xmlns="" xmlns:ma14="http://schemas.microsoft.com/office/mac/drawingml/2011/main" val="0"/>
+              <ma14:wrappingTextBoxFlag xmlns:ma14="http://schemas.microsoft.com/office/mac/drawingml/2011/main" xmlns="" val="0"/>
             </a:ext>
           </a:extLst>
         </p:spPr>
@@ -35639,7 +35651,7 @@
           </a:prstGeom>
           <a:extLst>
             <a:ext uri="{C572A759-6A51-4108-AA02-DFA0A04FC94B}">
-              <ma14:wrappingTextBoxFlag xmlns="" xmlns:ma14="http://schemas.microsoft.com/office/mac/drawingml/2011/main" val="0"/>
+              <ma14:wrappingTextBoxFlag xmlns:ma14="http://schemas.microsoft.com/office/mac/drawingml/2011/main" xmlns="" val="0"/>
             </a:ext>
           </a:extLst>
         </p:spPr>
@@ -36101,7 +36113,7 @@
           </a:prstGeom>
           <a:extLst>
             <a:ext uri="{C572A759-6A51-4108-AA02-DFA0A04FC94B}">
-              <ma14:wrappingTextBoxFlag xmlns="" xmlns:ma14="http://schemas.microsoft.com/office/mac/drawingml/2011/main" val="0"/>
+              <ma14:wrappingTextBoxFlag xmlns:ma14="http://schemas.microsoft.com/office/mac/drawingml/2011/main" xmlns="" val="0"/>
             </a:ext>
           </a:extLst>
         </p:spPr>
@@ -49532,7 +49544,7 @@
         </p:nvSpPr>
         <p:spPr>
           <a:xfrm>
-            <a:off x="1322834" y="3648067"/>
+            <a:off x="1322834" y="4481786"/>
             <a:ext cx="1552354" cy="1477328"/>
           </a:xfrm>
           <a:prstGeom prst="rect">
@@ -49777,7 +49789,7 @@
         <p:spPr>
           <a:xfrm flipV="1">
             <a:off x="2875188" y="3014856"/>
-            <a:ext cx="1745294" cy="1371875"/>
+            <a:ext cx="1745294" cy="2205594"/>
           </a:xfrm>
           <a:prstGeom prst="line">
             <a:avLst/>
@@ -49817,8 +49829,8 @@
         </p:nvCxnSpPr>
         <p:spPr>
           <a:xfrm>
-            <a:off x="2875188" y="4386731"/>
-            <a:ext cx="1754438" cy="1865251"/>
+            <a:off x="2875188" y="5220450"/>
+            <a:ext cx="1754438" cy="1031532"/>
           </a:xfrm>
           <a:prstGeom prst="line">
             <a:avLst/>

</xml_diff>